<commit_message>
Cambiar la diapositiva final: sin dirección para que el público entre
Co-Authored-By: Claude Opus 5.5 <noreply@anthropic.com>
Claude-Session: https://claude.ai/code/session_01HQzg5TszJSqz2d2ekWCWkY
</commit_message>
<xml_diff>
--- a/presentacion/Presentacion-Induccion.pptx
+++ b/presentacion/Presentacion-Induccion.pptx
@@ -1036,7 +1036,7 @@
           <a:p>
             <a:r>
               <a:rPr lang="en-US" dirty="0"/>
-              <a:t>Pasamos a la demo en vivo. Recorrido sugerido: Inicio → una estación (por ejemplo, Dónde va cada cosa) → un turno → el tablero → acceso supervisor.</a:t>
+              <a:t>Pasamos a mostrar la app nosotros desde el celular. Recorrido sugerido: Inicio → una estación (por ejemplo, Dónde va cada cosa) → un turno → el tablero → acceso supervisor.</a:t>
             </a:r>
             <a:endParaRPr lang="en-US" dirty="0"/>
           </a:p>
@@ -5019,7 +5019,7 @@
         </p:nvSpPr>
         <p:spPr>
           <a:xfrm>
-            <a:off x="548640" y="1234440"/>
+            <a:off x="548640" y="1463040"/>
             <a:ext cx="7315200" cy="274320"/>
           </a:xfrm>
           <a:prstGeom prst="rect">
@@ -5044,7 +5044,7 @@
                 <a:ea typeface="Arial" pitchFamily="34" charset="-122"/>
                 <a:cs typeface="Arial" pitchFamily="34" charset="-120"/>
               </a:rPr>
-              <a:t>DEMOSTRACIÓN</a:t>
+              <a:t>A CONTINUACIÓN</a:t>
             </a:r>
             <a:endParaRPr lang="en-US" sz="1100" dirty="0"/>
           </a:p>
@@ -5058,7 +5058,7 @@
         </p:nvSpPr>
         <p:spPr>
           <a:xfrm>
-            <a:off x="548640" y="1600200"/>
+            <a:off x="548640" y="1828800"/>
             <a:ext cx="5943600" cy="822960"/>
           </a:xfrm>
           <a:prstGeom prst="rect">
@@ -5083,7 +5083,7 @@
                 <a:ea typeface="Arial" pitchFamily="34" charset="-122"/>
                 <a:cs typeface="Arial" pitchFamily="34" charset="-120"/>
               </a:rPr>
-              <a:t>Veámosla funcionando</a:t>
+              <a:t>Ahora, probemos la app</a:t>
             </a:r>
             <a:endParaRPr lang="en-US" sz="3400" dirty="0"/>
           </a:p>
@@ -5097,24 +5097,24 @@
         </p:nvSpPr>
         <p:spPr>
           <a:xfrm>
-            <a:off x="548640" y="2697480"/>
-            <a:ext cx="5486400" cy="320040"/>
-          </a:xfrm>
-          <a:prstGeom prst="rect">
-            <a:avLst/>
-          </a:prstGeom>
-          <a:noFill/>
-          <a:ln/>
-        </p:spPr>
-        <p:txBody>
-          <a:bodyPr wrap="square" lIns="0" tIns="0" rIns="0" bIns="0" rtlCol="0" anchor="ctr"/>
-          <a:lstStyle/>
-          <a:p>
-            <a:pPr indent="0" marL="0">
-              <a:buNone/>
-            </a:pPr>
-            <a:r>
-              <a:rPr lang="en-US" sz="1500" dirty="0">
+            <a:off x="548640" y="2743200"/>
+            <a:ext cx="5303520" cy="731520"/>
+          </a:xfrm>
+          <a:prstGeom prst="rect">
+            <a:avLst/>
+          </a:prstGeom>
+          <a:noFill/>
+          <a:ln/>
+        </p:spPr>
+        <p:txBody>
+          <a:bodyPr wrap="square" lIns="0" tIns="0" rIns="0" bIns="0" rtlCol="0" anchor="t"/>
+          <a:lstStyle/>
+          <a:p>
+            <a:pPr indent="0" marL="0">
+              <a:buNone/>
+            </a:pPr>
+            <a:r>
+              <a:rPr lang="en-US" sz="1600" dirty="0">
                 <a:solidFill>
                   <a:srgbClr val="D9CFC2"/>
                 </a:solidFill>
@@ -5122,76 +5122,15 @@
                 <a:ea typeface="Calibri" pitchFamily="34" charset="-122"/>
                 <a:cs typeface="Calibri" pitchFamily="34" charset="-120"/>
               </a:rPr>
-              <a:t>Abrila en tu celular:</a:t>
-            </a:r>
-            <a:endParaRPr lang="en-US" sz="1500" dirty="0"/>
+              <a:t>La recorremos en vivo: una estación de entrenamiento, un turno simulado y el tablero de control.</a:t>
+            </a:r>
+            <a:endParaRPr lang="en-US" sz="1600" dirty="0"/>
           </a:p>
         </p:txBody>
       </p:sp>
       <p:sp>
         <p:nvSpPr>
           <p:cNvPr id="5" name="Shape 3"/>
-          <p:cNvSpPr/>
-          <p:nvPr/>
-        </p:nvSpPr>
-        <p:spPr>
-          <a:xfrm>
-            <a:off x="548640" y="3108960"/>
-            <a:ext cx="5394960" cy="548640"/>
-          </a:xfrm>
-          <a:prstGeom prst="roundRect">
-            <a:avLst>
-              <a:gd name="adj" fmla="val 16667"/>
-            </a:avLst>
-          </a:prstGeom>
-          <a:solidFill>
-            <a:srgbClr val="FFBC0D"/>
-          </a:solidFill>
-          <a:ln/>
-        </p:spPr>
-      </p:sp>
-      <p:sp>
-        <p:nvSpPr>
-          <p:cNvPr id="6" name="Text 4"/>
-          <p:cNvSpPr txBox="1"/>
-          <p:nvPr/>
-        </p:nvSpPr>
-        <p:spPr>
-          <a:xfrm>
-            <a:off x="548640" y="3108960"/>
-            <a:ext cx="5394960" cy="548640"/>
-          </a:xfrm>
-          <a:prstGeom prst="rect">
-            <a:avLst/>
-          </a:prstGeom>
-          <a:noFill/>
-          <a:ln/>
-        </p:spPr>
-        <p:txBody>
-          <a:bodyPr wrap="square" lIns="0" tIns="0" rIns="0" bIns="0" rtlCol="0" anchor="ctr"/>
-          <a:lstStyle/>
-          <a:p>
-            <a:pPr algn="ctr" indent="0" marL="0">
-              <a:buNone/>
-            </a:pPr>
-            <a:r>
-              <a:rPr lang="en-US" sz="1700" b="1" dirty="0">
-                <a:solidFill>
-                  <a:srgbClr val="1A1410"/>
-                </a:solidFill>
-                <a:latin typeface="Courier New" pitchFamily="34" charset="0"/>
-                <a:ea typeface="Courier New" pitchFamily="34" charset="-122"/>
-                <a:cs typeface="Courier New" pitchFamily="34" charset="-120"/>
-              </a:rPr>
-              <a:t>miayala03.github.io/Control-de-Gestion</a:t>
-            </a:r>
-            <a:endParaRPr lang="en-US" sz="1700" dirty="0"/>
-          </a:p>
-        </p:txBody>
-      </p:sp>
-      <p:sp>
-        <p:nvSpPr>
-          <p:cNvPr id="7" name="Shape 5"/>
           <p:cNvSpPr/>
           <p:nvPr/>
         </p:nvSpPr>
@@ -5220,7 +5159,7 @@
       </p:sp>
       <p:pic>
         <p:nvPicPr>
-          <p:cNvPr id="8" name="Image 0" descr="/tmp/claude-0/-home-user-Control-de-Gestion/7f4d1a78-df90-55c4-80bb-b6ebc9d47825/scratchpad/shots/turno.png">    </p:cNvPr>
+          <p:cNvPr id="6" name="Image 0" descr="/tmp/claude-0/-home-user-Control-de-Gestion/7f4d1a78-df90-55c4-80bb-b6ebc9d47825/scratchpad/shots/turno.png">    </p:cNvPr>
           <p:cNvPicPr>
             <a:picLocks noChangeAspect="1"/>
           </p:cNvPicPr>

</xml_diff>

<commit_message>
Pedir usuario y contraseña al abrir la app, con roles de trabajador y supervisor
- Pantalla de ingreso; las cuentas y sus roles están en el bloque usuarios de contenido.js
- Cada cuenta tiene su propio avance y sincroniza a una ficha fija en Firebase
- El supervisor entra directo al panel y ve a todo el equipo, incluso quien no ingresó
- Reemplaza el PIN del supervisor
- Corrige un error del gráfico de barras al sacar el puntero
- Actualiza README, la guía de Firebase y la diapositiva 6

Co-Authored-By: Claude Opus 5.5 <noreply@anthropic.com>
Claude-Session: https://claude.ai/code/session_01HQzg5TszJSqz2d2ekWCWkY
</commit_message>
<xml_diff>
--- a/presentacion/Presentacion-Induccion.pptx
+++ b/presentacion/Presentacion-Induccion.pptx
@@ -948,7 +948,7 @@
           <a:p>
             <a:r>
               <a:rPr lang="en-US" dirty="0"/>
-              <a:t>El avance viaja de la persona al supervisor por un código que se manda por mensaje, o automáticamente si está conectada la base en Firebase. Si una estación está baja para todos, el problema es del programa de inducción, no de la persona.</a:t>
+              <a:t>Al abrir la app cada uno ingresa con su usuario y contraseña, y el rol de la cuenta decide qué ve. El avance de cada trabajador le llega solo al supervisor a través de la base en Firebase. Si una estación está baja para todos, el problema es del programa de inducción, no de la persona.</a:t>
             </a:r>
             <a:endParaRPr lang="en-US" dirty="0"/>
           </a:p>
@@ -4694,7 +4694,7 @@
                 <a:ea typeface="Calibri" pitchFamily="34" charset="-122"/>
                 <a:cs typeface="Calibri" pitchFamily="34" charset="-120"/>
               </a:rPr>
-              <a:t>Entrena las 8 estaciones a su ritmo</a:t>
+              <a:t>Ingresa con su propio usuario</a:t>
             </a:r>
             <a:endParaRPr lang="en-US" sz="1400" dirty="0"/>
           </a:p>
@@ -4715,7 +4715,7 @@
                 <a:ea typeface="Calibri" pitchFamily="34" charset="-122"/>
                 <a:cs typeface="Calibri" pitchFamily="34" charset="-120"/>
               </a:rPr>
-              <a:t>Simula turnos y ve su desvío</a:t>
+              <a:t>Entrena las 8 estaciones a su ritmo</a:t>
             </a:r>
             <a:endParaRPr lang="en-US" sz="1400" dirty="0"/>
           </a:p>
@@ -4736,7 +4736,7 @@
                 <a:ea typeface="Calibri" pitchFamily="34" charset="-122"/>
                 <a:cs typeface="Calibri" pitchFamily="34" charset="-120"/>
               </a:rPr>
-              <a:t>Rinde la certificación</a:t>
+              <a:t>Simula turnos y ve su desvío</a:t>
             </a:r>
             <a:endParaRPr lang="en-US" sz="1400" dirty="0"/>
           </a:p>
@@ -4757,7 +4757,7 @@
                 <a:ea typeface="Calibri" pitchFamily="34" charset="-122"/>
                 <a:cs typeface="Calibri" pitchFamily="34" charset="-120"/>
               </a:rPr>
-              <a:t>Su avance queda guardado en su teléfono</a:t>
+              <a:t>Rinde la certificación</a:t>
             </a:r>
             <a:endParaRPr lang="en-US" sz="1400" dirty="0"/>
           </a:p>
@@ -4867,7 +4867,7 @@
                 <a:ea typeface="Arial" pitchFamily="34" charset="-122"/>
                 <a:cs typeface="Arial" pitchFamily="34" charset="-120"/>
               </a:rPr>
-              <a:t>Supervisor (con PIN)</a:t>
+              <a:t>Supervisor (admin)</a:t>
             </a:r>
             <a:endParaRPr lang="en-US" sz="1700" dirty="0"/>
           </a:p>

</xml_diff>